<commit_message>
added images for explainability
</commit_message>
<xml_diff>
--- a/peopleLikeMe/Presentation1.pptx
+++ b/peopleLikeMe/Presentation1.pptx
@@ -105,6 +105,11 @@
       </a:defRPr>
     </a:lvl9pPr>
   </p:defaultTextStyle>
+  <p:extLst>
+    <p:ext uri="{EFAFB233-063F-42B5-8137-9DF3F51BA10A}">
+      <p15:sldGuideLst xmlns:p15="http://schemas.microsoft.com/office/powerpoint/2012/main"/>
+    </p:ext>
+  </p:extLst>
 </p:presentation>
 </file>
 
@@ -255,7 +260,7 @@
           <a:p>
             <a:fld id="{2B92FFC2-1A74-4444-92E0-C51FBB64F6FC}" type="datetimeFigureOut">
               <a:rPr lang="en-US" smtClean="0"/>
-              <a:t>4/15/2026</a:t>
+              <a:t>4/17/2026</a:t>
             </a:fld>
             <a:endParaRPr lang="en-US"/>
           </a:p>
@@ -453,7 +458,7 @@
           <a:p>
             <a:fld id="{2B92FFC2-1A74-4444-92E0-C51FBB64F6FC}" type="datetimeFigureOut">
               <a:rPr lang="en-US" smtClean="0"/>
-              <a:t>4/15/2026</a:t>
+              <a:t>4/17/2026</a:t>
             </a:fld>
             <a:endParaRPr lang="en-US"/>
           </a:p>
@@ -661,7 +666,7 @@
           <a:p>
             <a:fld id="{2B92FFC2-1A74-4444-92E0-C51FBB64F6FC}" type="datetimeFigureOut">
               <a:rPr lang="en-US" smtClean="0"/>
-              <a:t>4/15/2026</a:t>
+              <a:t>4/17/2026</a:t>
             </a:fld>
             <a:endParaRPr lang="en-US"/>
           </a:p>
@@ -859,7 +864,7 @@
           <a:p>
             <a:fld id="{2B92FFC2-1A74-4444-92E0-C51FBB64F6FC}" type="datetimeFigureOut">
               <a:rPr lang="en-US" smtClean="0"/>
-              <a:t>4/15/2026</a:t>
+              <a:t>4/17/2026</a:t>
             </a:fld>
             <a:endParaRPr lang="en-US"/>
           </a:p>
@@ -1134,7 +1139,7 @@
           <a:p>
             <a:fld id="{2B92FFC2-1A74-4444-92E0-C51FBB64F6FC}" type="datetimeFigureOut">
               <a:rPr lang="en-US" smtClean="0"/>
-              <a:t>4/15/2026</a:t>
+              <a:t>4/17/2026</a:t>
             </a:fld>
             <a:endParaRPr lang="en-US"/>
           </a:p>
@@ -1399,7 +1404,7 @@
           <a:p>
             <a:fld id="{2B92FFC2-1A74-4444-92E0-C51FBB64F6FC}" type="datetimeFigureOut">
               <a:rPr lang="en-US" smtClean="0"/>
-              <a:t>4/15/2026</a:t>
+              <a:t>4/17/2026</a:t>
             </a:fld>
             <a:endParaRPr lang="en-US"/>
           </a:p>
@@ -1811,7 +1816,7 @@
           <a:p>
             <a:fld id="{2B92FFC2-1A74-4444-92E0-C51FBB64F6FC}" type="datetimeFigureOut">
               <a:rPr lang="en-US" smtClean="0"/>
-              <a:t>4/15/2026</a:t>
+              <a:t>4/17/2026</a:t>
             </a:fld>
             <a:endParaRPr lang="en-US"/>
           </a:p>
@@ -1952,7 +1957,7 @@
           <a:p>
             <a:fld id="{2B92FFC2-1A74-4444-92E0-C51FBB64F6FC}" type="datetimeFigureOut">
               <a:rPr lang="en-US" smtClean="0"/>
-              <a:t>4/15/2026</a:t>
+              <a:t>4/17/2026</a:t>
             </a:fld>
             <a:endParaRPr lang="en-US"/>
           </a:p>
@@ -2065,7 +2070,7 @@
           <a:p>
             <a:fld id="{2B92FFC2-1A74-4444-92E0-C51FBB64F6FC}" type="datetimeFigureOut">
               <a:rPr lang="en-US" smtClean="0"/>
-              <a:t>4/15/2026</a:t>
+              <a:t>4/17/2026</a:t>
             </a:fld>
             <a:endParaRPr lang="en-US"/>
           </a:p>
@@ -2376,7 +2381,7 @@
           <a:p>
             <a:fld id="{2B92FFC2-1A74-4444-92E0-C51FBB64F6FC}" type="datetimeFigureOut">
               <a:rPr lang="en-US" smtClean="0"/>
-              <a:t>4/15/2026</a:t>
+              <a:t>4/17/2026</a:t>
             </a:fld>
             <a:endParaRPr lang="en-US"/>
           </a:p>
@@ -2664,7 +2669,7 @@
           <a:p>
             <a:fld id="{2B92FFC2-1A74-4444-92E0-C51FBB64F6FC}" type="datetimeFigureOut">
               <a:rPr lang="en-US" smtClean="0"/>
-              <a:t>4/15/2026</a:t>
+              <a:t>4/17/2026</a:t>
             </a:fld>
             <a:endParaRPr lang="en-US"/>
           </a:p>
@@ -2905,7 +2910,7 @@
           <a:p>
             <a:fld id="{2B92FFC2-1A74-4444-92E0-C51FBB64F6FC}" type="datetimeFigureOut">
               <a:rPr lang="en-US" smtClean="0"/>
-              <a:t>4/15/2026</a:t>
+              <a:t>4/17/2026</a:t>
             </a:fld>
             <a:endParaRPr lang="en-US"/>
           </a:p>
@@ -3536,42 +3541,6 @@
           </a:p>
         </p:txBody>
       </p:sp>
-      <p:pic>
-        <p:nvPicPr>
-          <p:cNvPr id="3" name="Picture 2">
-            <a:extLst>
-              <a:ext uri="{FF2B5EF4-FFF2-40B4-BE49-F238E27FC236}">
-                <a16:creationId xmlns:a16="http://schemas.microsoft.com/office/drawing/2014/main" id="{D4BDE432-B730-CB2D-3D94-7B8F668ABB84}"/>
-              </a:ext>
-            </a:extLst>
-          </p:cNvPr>
-          <p:cNvPicPr>
-            <a:picLocks noChangeAspect="1"/>
-          </p:cNvPicPr>
-          <p:nvPr/>
-        </p:nvPicPr>
-        <p:blipFill>
-          <a:blip r:embed="rId2">
-            <a:extLst>
-              <a:ext uri="{28A0092B-C50C-407E-A947-70E740481C1C}">
-                <a14:useLocalDpi xmlns:a14="http://schemas.microsoft.com/office/drawing/2010/main" val="0"/>
-              </a:ext>
-            </a:extLst>
-          </a:blip>
-          <a:stretch>
-            <a:fillRect/>
-          </a:stretch>
-        </p:blipFill>
-        <p:spPr>
-          <a:xfrm>
-            <a:off x="6889813" y="643467"/>
-            <a:ext cx="4192227" cy="5571066"/>
-          </a:xfrm>
-          <a:prstGeom prst="rect">
-            <a:avLst/>
-          </a:prstGeom>
-        </p:spPr>
-      </p:pic>
       <p:sp>
         <p:nvSpPr>
           <p:cNvPr id="14" name="Rectangle 13">
@@ -3637,10 +3606,10 @@
       </p:sp>
       <p:pic>
         <p:nvPicPr>
-          <p:cNvPr id="5" name="Picture 4">
-            <a:extLst>
-              <a:ext uri="{FF2B5EF4-FFF2-40B4-BE49-F238E27FC236}">
-                <a16:creationId xmlns:a16="http://schemas.microsoft.com/office/drawing/2014/main" id="{E7AC8588-D14D-54A0-752A-7CBBE33CD300}"/>
+          <p:cNvPr id="8" name="Picture 7">
+            <a:extLst>
+              <a:ext uri="{FF2B5EF4-FFF2-40B4-BE49-F238E27FC236}">
+                <a16:creationId xmlns:a16="http://schemas.microsoft.com/office/drawing/2014/main" id="{1DE6FB01-D2C1-11D2-82FF-F23A6EAEE262}"/>
               </a:ext>
             </a:extLst>
           </p:cNvPr>
@@ -3650,33 +3619,57 @@
           <p:nvPr/>
         </p:nvPicPr>
         <p:blipFill>
-          <a:blip r:embed="rId3">
-            <a:extLst>
-              <a:ext uri="{28A0092B-C50C-407E-A947-70E740481C1C}">
-                <a14:useLocalDpi xmlns:a14="http://schemas.microsoft.com/office/drawing/2010/main" val="0"/>
-              </a:ext>
-            </a:extLst>
-          </a:blip>
+          <a:blip r:embed="rId2"/>
           <a:stretch>
             <a:fillRect/>
           </a:stretch>
         </p:blipFill>
         <p:spPr>
           <a:xfrm>
-            <a:off x="781262" y="643467"/>
-            <a:ext cx="4206154" cy="5571066"/>
+            <a:off x="477012" y="744183"/>
+            <a:ext cx="4995312" cy="4291597"/>
           </a:xfrm>
           <a:prstGeom prst="rect">
             <a:avLst/>
           </a:prstGeom>
         </p:spPr>
       </p:pic>
-      <p:sp>
-        <p:nvSpPr>
-          <p:cNvPr id="6" name="Rectangle: Rounded Corners 5">
-            <a:extLst>
-              <a:ext uri="{FF2B5EF4-FFF2-40B4-BE49-F238E27FC236}">
-                <a16:creationId xmlns:a16="http://schemas.microsoft.com/office/drawing/2014/main" id="{8941EFDA-9EB2-88EA-3365-454C58C0FF37}"/>
+      <p:pic>
+        <p:nvPicPr>
+          <p:cNvPr id="15" name="Picture 14">
+            <a:extLst>
+              <a:ext uri="{FF2B5EF4-FFF2-40B4-BE49-F238E27FC236}">
+                <a16:creationId xmlns:a16="http://schemas.microsoft.com/office/drawing/2014/main" id="{6551B14D-361B-4168-79EC-E8CEA296C345}"/>
+              </a:ext>
+            </a:extLst>
+          </p:cNvPr>
+          <p:cNvPicPr>
+            <a:picLocks noChangeAspect="1"/>
+          </p:cNvPicPr>
+          <p:nvPr/>
+        </p:nvPicPr>
+        <p:blipFill>
+          <a:blip r:embed="rId3"/>
+          <a:stretch>
+            <a:fillRect/>
+          </a:stretch>
+        </p:blipFill>
+        <p:spPr>
+          <a:xfrm>
+            <a:off x="6256866" y="480060"/>
+            <a:ext cx="5414539" cy="4555720"/>
+          </a:xfrm>
+          <a:prstGeom prst="rect">
+            <a:avLst/>
+          </a:prstGeom>
+        </p:spPr>
+      </p:pic>
+      <p:sp>
+        <p:nvSpPr>
+          <p:cNvPr id="27" name="Arrow: Left-Right 26">
+            <a:extLst>
+              <a:ext uri="{FF2B5EF4-FFF2-40B4-BE49-F238E27FC236}">
+                <a16:creationId xmlns:a16="http://schemas.microsoft.com/office/drawing/2014/main" id="{3168FB44-C301-654A-0CF4-FAA28F73E709}"/>
               </a:ext>
             </a:extLst>
           </p:cNvPr>
@@ -3685,222 +3678,16 @@
         </p:nvSpPr>
         <p:spPr>
           <a:xfrm>
-            <a:off x="781262" y="1524000"/>
-            <a:ext cx="2419138" cy="680720"/>
-          </a:xfrm>
-          <a:prstGeom prst="roundRect">
-            <a:avLst/>
-          </a:prstGeom>
-          <a:noFill/>
-          <a:ln w="44450">
-            <a:solidFill>
-              <a:srgbClr val="C00000"/>
-            </a:solidFill>
-          </a:ln>
-        </p:spPr>
-        <p:style>
-          <a:lnRef idx="2">
-            <a:schemeClr val="accent1">
-              <a:shade val="15000"/>
-            </a:schemeClr>
-          </a:lnRef>
-          <a:fillRef idx="1">
-            <a:schemeClr val="accent1"/>
-          </a:fillRef>
-          <a:effectRef idx="0">
-            <a:schemeClr val="accent1"/>
-          </a:effectRef>
-          <a:fontRef idx="minor">
-            <a:schemeClr val="lt1"/>
-          </a:fontRef>
-        </p:style>
-        <p:txBody>
-          <a:bodyPr rtlCol="0" anchor="ctr"/>
-          <a:lstStyle/>
-          <a:p>
-            <a:pPr algn="ctr"/>
-            <a:endParaRPr lang="en-US"/>
-          </a:p>
-        </p:txBody>
-      </p:sp>
-      <p:sp>
-        <p:nvSpPr>
-          <p:cNvPr id="7" name="Rectangle: Rounded Corners 6">
-            <a:extLst>
-              <a:ext uri="{FF2B5EF4-FFF2-40B4-BE49-F238E27FC236}">
-                <a16:creationId xmlns:a16="http://schemas.microsoft.com/office/drawing/2014/main" id="{8855422B-0F57-01F3-ADEB-066C3190292A}"/>
-              </a:ext>
-            </a:extLst>
-          </p:cNvPr>
-          <p:cNvSpPr/>
-          <p:nvPr/>
-        </p:nvSpPr>
-        <p:spPr>
-          <a:xfrm>
-            <a:off x="7123276" y="1524000"/>
-            <a:ext cx="3732791" cy="830094"/>
-          </a:xfrm>
-          <a:prstGeom prst="roundRect">
-            <a:avLst/>
-          </a:prstGeom>
-          <a:noFill/>
-          <a:ln w="44450">
-            <a:solidFill>
-              <a:srgbClr val="C00000"/>
-            </a:solidFill>
-          </a:ln>
-        </p:spPr>
-        <p:style>
-          <a:lnRef idx="2">
-            <a:schemeClr val="accent1">
-              <a:shade val="15000"/>
-            </a:schemeClr>
-          </a:lnRef>
-          <a:fillRef idx="1">
-            <a:schemeClr val="accent1"/>
-          </a:fillRef>
-          <a:effectRef idx="0">
-            <a:schemeClr val="accent1"/>
-          </a:effectRef>
-          <a:fontRef idx="minor">
-            <a:schemeClr val="lt1"/>
-          </a:fontRef>
-        </p:style>
-        <p:txBody>
-          <a:bodyPr rtlCol="0" anchor="ctr"/>
-          <a:lstStyle/>
-          <a:p>
-            <a:pPr algn="ctr"/>
-            <a:endParaRPr lang="en-US"/>
-          </a:p>
-        </p:txBody>
-      </p:sp>
-      <p:sp>
-        <p:nvSpPr>
-          <p:cNvPr id="9" name="Rectangle: Rounded Corners 8">
-            <a:extLst>
-              <a:ext uri="{FF2B5EF4-FFF2-40B4-BE49-F238E27FC236}">
-                <a16:creationId xmlns:a16="http://schemas.microsoft.com/office/drawing/2014/main" id="{148B42F6-8077-02B6-B4EC-88FA084C8F55}"/>
-              </a:ext>
-            </a:extLst>
-          </p:cNvPr>
-          <p:cNvSpPr/>
-          <p:nvPr/>
-        </p:nvSpPr>
-        <p:spPr>
-          <a:xfrm>
-            <a:off x="710119" y="2999360"/>
-            <a:ext cx="2642681" cy="1280810"/>
-          </a:xfrm>
-          <a:prstGeom prst="roundRect">
-            <a:avLst/>
-          </a:prstGeom>
-          <a:noFill/>
-          <a:ln w="44450">
-            <a:solidFill>
-              <a:srgbClr val="00B050"/>
-            </a:solidFill>
-          </a:ln>
-        </p:spPr>
-        <p:style>
-          <a:lnRef idx="2">
-            <a:schemeClr val="accent1">
-              <a:shade val="15000"/>
-            </a:schemeClr>
-          </a:lnRef>
-          <a:fillRef idx="1">
-            <a:schemeClr val="accent1"/>
-          </a:fillRef>
-          <a:effectRef idx="0">
-            <a:schemeClr val="accent1"/>
-          </a:effectRef>
-          <a:fontRef idx="minor">
-            <a:schemeClr val="lt1"/>
-          </a:fontRef>
-        </p:style>
-        <p:txBody>
-          <a:bodyPr rtlCol="0" anchor="ctr"/>
-          <a:lstStyle/>
-          <a:p>
-            <a:pPr algn="ctr"/>
-            <a:endParaRPr lang="en-US"/>
-          </a:p>
-        </p:txBody>
-      </p:sp>
-      <p:sp>
-        <p:nvSpPr>
-          <p:cNvPr id="11" name="Rectangle: Rounded Corners 10">
-            <a:extLst>
-              <a:ext uri="{FF2B5EF4-FFF2-40B4-BE49-F238E27FC236}">
-                <a16:creationId xmlns:a16="http://schemas.microsoft.com/office/drawing/2014/main" id="{26639FF9-D04D-06F1-0D10-96222F0415D5}"/>
-              </a:ext>
-            </a:extLst>
-          </p:cNvPr>
-          <p:cNvSpPr/>
-          <p:nvPr/>
-        </p:nvSpPr>
-        <p:spPr>
-          <a:xfrm>
-            <a:off x="7123276" y="3936458"/>
-            <a:ext cx="3958764" cy="1608308"/>
-          </a:xfrm>
-          <a:prstGeom prst="roundRect">
-            <a:avLst/>
-          </a:prstGeom>
-          <a:noFill/>
-          <a:ln w="44450">
-            <a:solidFill>
-              <a:srgbClr val="00B050"/>
-            </a:solidFill>
-          </a:ln>
-        </p:spPr>
-        <p:style>
-          <a:lnRef idx="2">
-            <a:schemeClr val="accent1">
-              <a:shade val="15000"/>
-            </a:schemeClr>
-          </a:lnRef>
-          <a:fillRef idx="1">
-            <a:schemeClr val="accent1"/>
-          </a:fillRef>
-          <a:effectRef idx="0">
-            <a:schemeClr val="accent1"/>
-          </a:effectRef>
-          <a:fontRef idx="minor">
-            <a:schemeClr val="lt1"/>
-          </a:fontRef>
-        </p:style>
-        <p:txBody>
-          <a:bodyPr rtlCol="0" anchor="ctr"/>
-          <a:lstStyle/>
-          <a:p>
-            <a:pPr algn="ctr"/>
-            <a:endParaRPr lang="en-US"/>
-          </a:p>
-        </p:txBody>
-      </p:sp>
-      <p:sp>
-        <p:nvSpPr>
-          <p:cNvPr id="27" name="Arrow: Left-Right 26">
-            <a:extLst>
-              <a:ext uri="{FF2B5EF4-FFF2-40B4-BE49-F238E27FC236}">
-                <a16:creationId xmlns:a16="http://schemas.microsoft.com/office/drawing/2014/main" id="{3168FB44-C301-654A-0CF4-FAA28F73E709}"/>
-              </a:ext>
-            </a:extLst>
-          </p:cNvPr>
-          <p:cNvSpPr/>
-          <p:nvPr/>
-        </p:nvSpPr>
-        <p:spPr>
-          <a:xfrm>
-            <a:off x="4380271" y="1591346"/>
-            <a:ext cx="2348676" cy="546027"/>
+            <a:off x="4681264" y="1474949"/>
+            <a:ext cx="2029947" cy="546027"/>
           </a:xfrm>
           <a:prstGeom prst="leftRightArrow">
             <a:avLst/>
           </a:prstGeom>
           <a:solidFill>
-            <a:srgbClr val="C00000"/>
+            <a:schemeClr val="accent2">
+              <a:lumMod val="75000"/>
+            </a:schemeClr>
           </a:solidFill>
         </p:spPr>
         <p:style>
@@ -3944,9 +3731,9 @@
           <p:nvPr/>
         </p:nvSpPr>
         <p:spPr>
-          <a:xfrm rot="567786">
-            <a:off x="4012492" y="3300728"/>
-            <a:ext cx="2666356" cy="546027"/>
+          <a:xfrm>
+            <a:off x="4571994" y="2419042"/>
+            <a:ext cx="2170345" cy="546027"/>
           </a:xfrm>
           <a:prstGeom prst="leftRightArrow">
             <a:avLst/>
@@ -4000,9 +3787,9 @@
           <p:nvPr/>
         </p:nvSpPr>
         <p:spPr>
-          <a:xfrm rot="567786">
-            <a:off x="3874979" y="3984643"/>
-            <a:ext cx="2666356" cy="546027"/>
+          <a:xfrm>
+            <a:off x="4538133" y="3255364"/>
+            <a:ext cx="2271945" cy="546027"/>
           </a:xfrm>
           <a:prstGeom prst="leftRightArrow">
             <a:avLst/>
@@ -4036,6 +3823,100 @@
               <a:rPr lang="en-US" dirty="0"/>
               <a:t>1:many, top n</a:t>
             </a:r>
+          </a:p>
+        </p:txBody>
+      </p:sp>
+      <p:sp>
+        <p:nvSpPr>
+          <p:cNvPr id="16" name="Rectangle: Rounded Corners 15">
+            <a:extLst>
+              <a:ext uri="{FF2B5EF4-FFF2-40B4-BE49-F238E27FC236}">
+                <a16:creationId xmlns:a16="http://schemas.microsoft.com/office/drawing/2014/main" id="{EE0C2AB8-8F49-55BB-7CE8-0E345B2E908A}"/>
+              </a:ext>
+            </a:extLst>
+          </p:cNvPr>
+          <p:cNvSpPr/>
+          <p:nvPr/>
+        </p:nvSpPr>
+        <p:spPr>
+          <a:xfrm>
+            <a:off x="477012" y="1244600"/>
+            <a:ext cx="11194393" cy="884147"/>
+          </a:xfrm>
+          <a:prstGeom prst="roundRect">
+            <a:avLst/>
+          </a:prstGeom>
+          <a:noFill/>
+        </p:spPr>
+        <p:style>
+          <a:lnRef idx="2">
+            <a:schemeClr val="accent1">
+              <a:shade val="15000"/>
+            </a:schemeClr>
+          </a:lnRef>
+          <a:fillRef idx="1">
+            <a:schemeClr val="accent1"/>
+          </a:fillRef>
+          <a:effectRef idx="0">
+            <a:schemeClr val="accent1"/>
+          </a:effectRef>
+          <a:fontRef idx="minor">
+            <a:schemeClr val="lt1"/>
+          </a:fontRef>
+        </p:style>
+        <p:txBody>
+          <a:bodyPr rtlCol="0" anchor="ctr"/>
+          <a:lstStyle/>
+          <a:p>
+            <a:pPr algn="ctr"/>
+            <a:endParaRPr lang="en-US"/>
+          </a:p>
+        </p:txBody>
+      </p:sp>
+      <p:sp>
+        <p:nvSpPr>
+          <p:cNvPr id="17" name="Rectangle: Rounded Corners 16">
+            <a:extLst>
+              <a:ext uri="{FF2B5EF4-FFF2-40B4-BE49-F238E27FC236}">
+                <a16:creationId xmlns:a16="http://schemas.microsoft.com/office/drawing/2014/main" id="{DF960D39-01BF-D019-2DBF-0B5392607B68}"/>
+              </a:ext>
+            </a:extLst>
+          </p:cNvPr>
+          <p:cNvSpPr/>
+          <p:nvPr/>
+        </p:nvSpPr>
+        <p:spPr>
+          <a:xfrm>
+            <a:off x="477012" y="2129368"/>
+            <a:ext cx="11194393" cy="1672023"/>
+          </a:xfrm>
+          <a:prstGeom prst="roundRect">
+            <a:avLst/>
+          </a:prstGeom>
+          <a:noFill/>
+        </p:spPr>
+        <p:style>
+          <a:lnRef idx="2">
+            <a:schemeClr val="accent1">
+              <a:shade val="15000"/>
+            </a:schemeClr>
+          </a:lnRef>
+          <a:fillRef idx="1">
+            <a:schemeClr val="accent1"/>
+          </a:fillRef>
+          <a:effectRef idx="0">
+            <a:schemeClr val="accent1"/>
+          </a:effectRef>
+          <a:fontRef idx="minor">
+            <a:schemeClr val="lt1"/>
+          </a:fontRef>
+        </p:style>
+        <p:txBody>
+          <a:bodyPr rtlCol="0" anchor="ctr"/>
+          <a:lstStyle/>
+          <a:p>
+            <a:pPr algn="ctr"/>
+            <a:endParaRPr lang="en-US"/>
           </a:p>
         </p:txBody>
       </p:sp>

</xml_diff>